<commit_message>
Stage 8 review fixes: F-006
</commit_message>
<xml_diff>
--- a/output/archive/DurnesswickData/Marketing/Working_Copies/2025/Copy of stability-cross-sell_031225.pptx
+++ b/output/archive/DurnesswickData/Marketing/Working_Copies/2025/Copy of stability-cross-sell_031225.pptx
@@ -580,7 +580,7 @@
           <a:lstStyle/>
           <a:p>
             <a:r>
-              <a:t>Julia's wording for the scale gate is clearer than mine. Use hers in the client version. LP</a:t>
+              <a:t>LP: Westravelle sequence sheets and system-suitability terminology retained from the source overview. Julia: distinguish our exploratory vehicle ladder and excipient compatibility screen from the formulation set locked at the scale gate.</a:t>
             </a:r>
           </a:p>
         </p:txBody>
@@ -3758,7 +3758,7 @@
                 </a:solidFill>
                 <a:latin typeface="Arial"/>
               </a:rPr>
-              <a:t>Durnesswick Laboratories Inc, a Tarnovell company | Working copy 03/12/2025</a:t>
+              <a:t>Durnesswick Laboratories Inc, a Tarnovell company | Copy of Westravelle stability-services overview | Working copy 03/12/2025</a:t>
             </a:r>
           </a:p>
         </p:txBody>
@@ -3841,7 +3841,7 @@
               <a:rPr sz="2000">
                 <a:latin typeface="Arial"/>
               </a:rPr>
-              <a:t>Most early formulations go on to stability work within a year of the first pilot lot</a:t>
+              <a:t>Stability planning follows the intended formulation, pack and storage conditions</a:t>
             </a:r>
           </a:p>
           <a:p>
@@ -3850,7 +3850,7 @@
               <a:rPr sz="1700">
                 <a:latin typeface="Arial"/>
               </a:rPr>
-              <a:t>Clients want one point of contact from the formulation set through to the stability data</a:t>
+              <a:t>Clients need an agreed handoff from formulation development to the stability protocol</a:t>
             </a:r>
           </a:p>
           <a:p>
@@ -3859,7 +3859,7 @@
               <a:rPr sz="2000">
                 <a:latin typeface="Arial"/>
               </a:rPr>
-              <a:t>The handoff is where timelines usually slip</a:t>
+              <a:t>Confirm responsibilities and sample readiness before agreeing the pull schedule</a:t>
             </a:r>
           </a:p>
           <a:p>
@@ -3868,7 +3868,7 @@
               <a:rPr sz="1700">
                 <a:latin typeface="Arial"/>
               </a:rPr>
-              <a:t>Excipient choice made at screen stage constrains what can be tested later</a:t>
+              <a:t>Exploratory excipient screens do not establish a locked manufacturing process</a:t>
             </a:r>
           </a:p>
         </p:txBody>
@@ -3996,73 +3996,14 @@
                 </a:solidFill>
                 <a:latin typeface="Arial"/>
               </a:rPr>
-              <a:t>What Durnesswick runs in-house</a:t>
-            </a:r>
-          </a:p>
-        </p:txBody>
-      </p:sp>
-      <p:sp>
-        <p:nvSpPr>
-          <p:cNvPr id="3" name="Content Placeholder 2"/>
-          <p:cNvSpPr>
-            <a:spLocks noGrp="1"/>
-          </p:cNvSpPr>
-          <p:nvPr>
-            <p:ph idx="1"/>
-          </p:nvPr>
-        </p:nvSpPr>
-        <p:spPr>
-          <a:xfrm>
-            <a:off x="457200" y="1280160"/>
-            <a:ext cx="11277295" cy="4937760"/>
-          </a:xfrm>
-        </p:spPr>
-        <p:txBody>
-          <a:bodyPr wrap="square">
-            <a:noAutofit/>
-          </a:bodyPr>
-          <a:lstStyle/>
-          <a:p>
-            <a:pPr/>
-            <a:r>
-              <a:rPr sz="2000">
-                <a:latin typeface="Arial"/>
-              </a:rPr>
-              <a:t>Vehicle ladder for early solubility and vehicle screening</a:t>
-            </a:r>
-          </a:p>
-          <a:p>
-            <a:pPr/>
-            <a:r>
-              <a:rPr sz="2000">
-                <a:latin typeface="Arial"/>
-              </a:rPr>
-              <a:t>Excipient compatibility screen before a formulation set is locked</a:t>
-            </a:r>
-          </a:p>
-          <a:p>
-            <a:pPr/>
-            <a:r>
-              <a:rPr sz="2000">
-                <a:latin typeface="Arial"/>
-              </a:rPr>
-              <a:t>Pre-formulation work on the active to set the loading range</a:t>
-            </a:r>
-          </a:p>
-          <a:p>
-            <a:pPr/>
-            <a:r>
-              <a:rPr sz="2000">
-                <a:latin typeface="Arial"/>
-              </a:rPr>
-              <a:t>Pilot lot manufacture and the scale gate report</a:t>
-            </a:r>
-          </a:p>
-        </p:txBody>
-      </p:sp>
-      <p:sp>
-        <p:nvSpPr>
-          <p:cNvPr id="4" name="Rectangle 3"/>
+              <a:t>Westravelle: ICH chamber programme</a:t>
+            </a:r>
+          </a:p>
+        </p:txBody>
+      </p:sp>
+      <p:sp>
+        <p:nvSpPr>
+          <p:cNvPr id="3" name="Rectangle 2"/>
           <p:cNvSpPr/>
           <p:nvPr/>
         </p:nvSpPr>
@@ -4103,6 +4044,242 @@
           </a:p>
         </p:txBody>
       </p:sp>
+      <p:graphicFrame>
+        <p:nvGraphicFramePr>
+          <p:cNvPr id="4" name="Table 3"/>
+          <p:cNvGraphicFramePr>
+            <a:graphicFrameLocks noGrp="1"/>
+          </p:cNvGraphicFramePr>
+          <p:nvPr/>
+        </p:nvGraphicFramePr>
+        <p:xfrm>
+          <a:off x="457200" y="1280160"/>
+          <a:ext cx="11277295" cy="1097280"/>
+        </p:xfrm>
+        <a:graphic>
+          <a:graphicData uri="http://schemas.openxmlformats.org/drawingml/2006/table">
+            <a:tbl>
+              <a:tblPr firstRow="1" bandRow="1">
+                <a:tableStyleId>{5C22544A-7EE6-4342-B048-85BDC9FD1C3A}</a:tableStyleId>
+              </a:tblPr>
+              <a:tblGrid>
+                <a:gridCol w="3759098"/>
+                <a:gridCol w="3759098"/>
+                <a:gridCol w="3759099"/>
+              </a:tblGrid>
+              <a:tr h="274320">
+                <a:tc>
+                  <a:txBody>
+                    <a:bodyPr/>
+                    <a:lstStyle/>
+                    <a:p>
+                      <a:r>
+                        <a:rPr sz="1400" b="1">
+                          <a:solidFill>
+                            <a:srgbClr val="FFFFFF"/>
+                          </a:solidFill>
+                          <a:latin typeface="Arial"/>
+                        </a:rPr>
+                        <a:t>Service / sequence sheet</a:t>
+                      </a:r>
+                    </a:p>
+                  </a:txBody>
+                  <a:tcPr>
+                    <a:solidFill>
+                      <a:srgbClr val="183C4C"/>
+                    </a:solidFill>
+                  </a:tcPr>
+                </a:tc>
+                <a:tc>
+                  <a:txBody>
+                    <a:bodyPr/>
+                    <a:lstStyle/>
+                    <a:p>
+                      <a:r>
+                        <a:rPr sz="1400" b="1">
+                          <a:solidFill>
+                            <a:srgbClr val="FFFFFF"/>
+                          </a:solidFill>
+                          <a:latin typeface="Arial"/>
+                        </a:rPr>
+                        <a:t>Scope</a:t>
+                      </a:r>
+                    </a:p>
+                  </a:txBody>
+                  <a:tcPr>
+                    <a:solidFill>
+                      <a:srgbClr val="183C4C"/>
+                    </a:solidFill>
+                  </a:tcPr>
+                </a:tc>
+                <a:tc>
+                  <a:txBody>
+                    <a:bodyPr/>
+                    <a:lstStyle/>
+                    <a:p>
+                      <a:r>
+                        <a:rPr sz="1400" b="1">
+                          <a:solidFill>
+                            <a:srgbClr val="FFFFFF"/>
+                          </a:solidFill>
+                          <a:latin typeface="Arial"/>
+                        </a:rPr>
+                        <a:t>Responsible site</a:t>
+                      </a:r>
+                    </a:p>
+                  </a:txBody>
+                  <a:tcPr>
+                    <a:solidFill>
+                      <a:srgbClr val="183C4C"/>
+                    </a:solidFill>
+                  </a:tcPr>
+                </a:tc>
+              </a:tr>
+              <a:tr h="274320">
+                <a:tc>
+                  <a:txBody>
+                    <a:bodyPr/>
+                    <a:lstStyle/>
+                    <a:p>
+                      <a:r>
+                        <a:rPr sz="1400">
+                          <a:latin typeface="Arial"/>
+                        </a:rPr>
+                        <a:t>ICH chamber programme</a:t>
+                      </a:r>
+                    </a:p>
+                  </a:txBody>
+                  <a:tcPr/>
+                </a:tc>
+                <a:tc>
+                  <a:txBody>
+                    <a:bodyPr/>
+                    <a:lstStyle/>
+                    <a:p>
+                      <a:r>
+                        <a:rPr sz="1400">
+                          <a:latin typeface="Arial"/>
+                        </a:rPr>
+                        <a:t>Storage conditions and pull schedule defined in the stability protocol</a:t>
+                      </a:r>
+                    </a:p>
+                  </a:txBody>
+                  <a:tcPr/>
+                </a:tc>
+                <a:tc>
+                  <a:txBody>
+                    <a:bodyPr/>
+                    <a:lstStyle/>
+                    <a:p>
+                      <a:r>
+                        <a:rPr sz="1400">
+                          <a:latin typeface="Arial"/>
+                        </a:rPr>
+                        <a:t>Westravelle Analytical, York</a:t>
+                      </a:r>
+                    </a:p>
+                  </a:txBody>
+                  <a:tcPr/>
+                </a:tc>
+              </a:tr>
+              <a:tr h="274320">
+                <a:tc>
+                  <a:txBody>
+                    <a:bodyPr/>
+                    <a:lstStyle/>
+                    <a:p>
+                      <a:r>
+                        <a:rPr sz="1400">
+                          <a:latin typeface="Arial"/>
+                        </a:rPr>
+                        <a:t>Stability pulls</a:t>
+                      </a:r>
+                    </a:p>
+                  </a:txBody>
+                  <a:tcPr/>
+                </a:tc>
+                <a:tc>
+                  <a:txBody>
+                    <a:bodyPr/>
+                    <a:lstStyle/>
+                    <a:p>
+                      <a:r>
+                        <a:rPr sz="1400">
+                          <a:latin typeface="Arial"/>
+                        </a:rPr>
+                        <a:t>Assay (% label claim), related substances (% area) and water where specified</a:t>
+                      </a:r>
+                    </a:p>
+                  </a:txBody>
+                  <a:tcPr/>
+                </a:tc>
+                <a:tc>
+                  <a:txBody>
+                    <a:bodyPr/>
+                    <a:lstStyle/>
+                    <a:p>
+                      <a:r>
+                        <a:rPr sz="1400">
+                          <a:latin typeface="Arial"/>
+                        </a:rPr>
+                        <a:t>Westravelle Analytical, York</a:t>
+                      </a:r>
+                    </a:p>
+                  </a:txBody>
+                  <a:tcPr/>
+                </a:tc>
+              </a:tr>
+              <a:tr h="274320">
+                <a:tc>
+                  <a:txBody>
+                    <a:bodyPr/>
+                    <a:lstStyle/>
+                    <a:p>
+                      <a:r>
+                        <a:rPr sz="1400">
+                          <a:latin typeface="Arial"/>
+                        </a:rPr>
+                        <a:t>HPLC method qualification</a:t>
+                      </a:r>
+                    </a:p>
+                  </a:txBody>
+                  <a:tcPr/>
+                </a:tc>
+                <a:tc>
+                  <a:txBody>
+                    <a:bodyPr/>
+                    <a:lstStyle/>
+                    <a:p>
+                      <a:r>
+                        <a:rPr sz="1400">
+                          <a:latin typeface="Arial"/>
+                        </a:rPr>
+                        <a:t>Assay and related-substances validation before routine reporting</a:t>
+                      </a:r>
+                    </a:p>
+                  </a:txBody>
+                  <a:tcPr/>
+                </a:tc>
+                <a:tc>
+                  <a:txBody>
+                    <a:bodyPr/>
+                    <a:lstStyle/>
+                    <a:p>
+                      <a:r>
+                        <a:rPr sz="1400">
+                          <a:latin typeface="Arial"/>
+                        </a:rPr>
+                        <a:t>Westravelle Analytical, York</a:t>
+                      </a:r>
+                    </a:p>
+                  </a:txBody>
+                  <a:tcPr/>
+                </a:tc>
+              </a:tr>
+            </a:tbl>
+          </a:graphicData>
+        </a:graphic>
+      </p:graphicFrame>
       <p:sp>
         <p:nvSpPr>
           <p:cNvPr id="5" name="TextBox 4"/>

</xml_diff>